<commit_message>
Make References slide links clickable in PPTX
Co-authored-by: Copilot <223556219+Copilot@users.noreply.github.com>
</commit_message>
<xml_diff>
--- a/slides/What to use when - Copilot and Cowork (Business - lite).pptx
+++ b/slides/What to use when - Copilot and Cowork (Business - lite).pptx
@@ -11905,7 +11905,7 @@
           <a:noFill/>
         </p:spPr>
         <p:txBody>
-          <a:bodyPr wrap="none" lIns="73152" rIns="73152" tIns="36576">
+          <a:bodyPr wrap="square" lIns="73152" rIns="73152" tIns="36576">
             <a:spAutoFit/>
           </a:bodyPr>
           <a:lstStyle/>
@@ -11914,15 +11914,25 @@
               <a:spcAft>
                 <a:spcPts val="500"/>
               </a:spcAft>
-              <a:defRPr sz="1200">
+            </a:pPr>
+            <a:r>
+              <a:rPr sz="1200">
                 <a:solidFill>
                   <a:srgbClr val="1B1B2C"/>
                 </a:solidFill>
                 <a:latin typeface="Segoe UI"/>
-              </a:defRPr>
-            </a:pPr>
-            <a:r>
-              <a:t>• LEARN Decide which Copilot is right for you</a:t>
+              </a:rPr>
+              <a:t>• </a:t>
+            </a:r>
+            <a:r>
+              <a:rPr sz="1200" u="sng">
+                <a:solidFill>
+                  <a:srgbClr val="1A6FD6"/>
+                </a:solidFill>
+                <a:latin typeface="Segoe UI"/>
+                <a:hlinkClick r:id="rId2"/>
+              </a:rPr>
+              <a:t>LEARN Decide which Copilot is right for you</a:t>
             </a:r>
           </a:p>
           <a:p>
@@ -11930,15 +11940,25 @@
               <a:spcAft>
                 <a:spcPts val="500"/>
               </a:spcAft>
-              <a:defRPr sz="1200">
+            </a:pPr>
+            <a:r>
+              <a:rPr sz="1200">
                 <a:solidFill>
                   <a:srgbClr val="1B1B2C"/>
                 </a:solidFill>
                 <a:latin typeface="Segoe UI"/>
-              </a:defRPr>
-            </a:pPr>
-            <a:r>
-              <a:t>• LEARN Copilot Cowork overview</a:t>
+              </a:rPr>
+              <a:t>• </a:t>
+            </a:r>
+            <a:r>
+              <a:rPr sz="1200" u="sng">
+                <a:solidFill>
+                  <a:srgbClr val="1A6FD6"/>
+                </a:solidFill>
+                <a:latin typeface="Segoe UI"/>
+                <a:hlinkClick r:id="rId3"/>
+              </a:rPr>
+              <a:t>LEARN Copilot Cowork overview</a:t>
             </a:r>
           </a:p>
           <a:p>
@@ -11946,15 +11966,25 @@
               <a:spcAft>
                 <a:spcPts val="500"/>
               </a:spcAft>
-              <a:defRPr sz="1200">
+            </a:pPr>
+            <a:r>
+              <a:rPr sz="1200">
                 <a:solidFill>
                   <a:srgbClr val="1B1B2C"/>
                 </a:solidFill>
                 <a:latin typeface="Segoe UI"/>
-              </a:defRPr>
-            </a:pPr>
-            <a:r>
-              <a:t>• LEARN Copilot Cowork common questions</a:t>
+              </a:rPr>
+              <a:t>• </a:t>
+            </a:r>
+            <a:r>
+              <a:rPr sz="1200" u="sng">
+                <a:solidFill>
+                  <a:srgbClr val="1A6FD6"/>
+                </a:solidFill>
+                <a:latin typeface="Segoe UI"/>
+                <a:hlinkClick r:id="rId4"/>
+              </a:rPr>
+              <a:t>LEARN Copilot Cowork common questions</a:t>
             </a:r>
           </a:p>
           <a:p>
@@ -11962,15 +11992,25 @@
               <a:spcAft>
                 <a:spcPts val="500"/>
               </a:spcAft>
-              <a:defRPr sz="1200">
+            </a:pPr>
+            <a:r>
+              <a:rPr sz="1200">
                 <a:solidFill>
                   <a:srgbClr val="1B1B2C"/>
                 </a:solidFill>
                 <a:latin typeface="Segoe UI"/>
-              </a:defRPr>
-            </a:pPr>
-            <a:r>
-              <a:t>• LEARN Researcher agent in Microsoft 365 Copilot</a:t>
+              </a:rPr>
+              <a:t>• </a:t>
+            </a:r>
+            <a:r>
+              <a:rPr sz="1200" u="sng">
+                <a:solidFill>
+                  <a:srgbClr val="1A6FD6"/>
+                </a:solidFill>
+                <a:latin typeface="Segoe UI"/>
+                <a:hlinkClick r:id="rId5"/>
+              </a:rPr>
+              <a:t>LEARN Researcher agent in Microsoft 365 Copilot</a:t>
             </a:r>
           </a:p>
           <a:p>
@@ -11978,15 +12018,25 @@
               <a:spcAft>
                 <a:spcPts val="500"/>
               </a:spcAft>
-              <a:defRPr sz="1200">
+            </a:pPr>
+            <a:r>
+              <a:rPr sz="1200">
                 <a:solidFill>
                   <a:srgbClr val="1B1B2C"/>
                 </a:solidFill>
                 <a:latin typeface="Segoe UI"/>
-              </a:defRPr>
-            </a:pPr>
-            <a:r>
-              <a:t>• LEARN Agents for Microsoft 365 Copilot Chat</a:t>
+              </a:rPr>
+              <a:t>• </a:t>
+            </a:r>
+            <a:r>
+              <a:rPr sz="1200" u="sng">
+                <a:solidFill>
+                  <a:srgbClr val="1A6FD6"/>
+                </a:solidFill>
+                <a:latin typeface="Segoe UI"/>
+                <a:hlinkClick r:id="rId6"/>
+              </a:rPr>
+              <a:t>LEARN Agents for Microsoft 365 Copilot Chat</a:t>
             </a:r>
           </a:p>
           <a:p>
@@ -11994,15 +12044,25 @@
               <a:spcAft>
                 <a:spcPts val="500"/>
               </a:spcAft>
-              <a:defRPr sz="1200">
+            </a:pPr>
+            <a:r>
+              <a:rPr sz="1200">
                 <a:solidFill>
                   <a:srgbClr val="1B1B2C"/>
                 </a:solidFill>
                 <a:latin typeface="Segoe UI"/>
-              </a:defRPr>
-            </a:pPr>
-            <a:r>
-              <a:t>• SUPPORT Schedule your most used Copilot prompts</a:t>
+              </a:rPr>
+              <a:t>• </a:t>
+            </a:r>
+            <a:r>
+              <a:rPr sz="1200" u="sng">
+                <a:solidFill>
+                  <a:srgbClr val="1A6FD6"/>
+                </a:solidFill>
+                <a:latin typeface="Segoe UI"/>
+                <a:hlinkClick r:id="rId7"/>
+              </a:rPr>
+              <a:t>SUPPORT Schedule your most used Copilot prompts</a:t>
             </a:r>
           </a:p>
           <a:p>
@@ -12010,15 +12070,25 @@
               <a:spcAft>
                 <a:spcPts val="500"/>
               </a:spcAft>
-              <a:defRPr sz="1200">
+            </a:pPr>
+            <a:r>
+              <a:rPr sz="1200">
                 <a:solidFill>
                   <a:srgbClr val="1B1B2C"/>
                 </a:solidFill>
                 <a:latin typeface="Segoe UI"/>
-              </a:defRPr>
-            </a:pPr>
-            <a:r>
-              <a:t>• ADOPT Cowork for the AI user (prompt structure)</a:t>
+              </a:rPr>
+              <a:t>• </a:t>
+            </a:r>
+            <a:r>
+              <a:rPr sz="1200" u="sng">
+                <a:solidFill>
+                  <a:srgbClr val="1A6FD6"/>
+                </a:solidFill>
+                <a:latin typeface="Segoe UI"/>
+                <a:hlinkClick r:id="rId8"/>
+              </a:rPr>
+              <a:t>ADOPT Cowork for the AI user (prompt structure)</a:t>
             </a:r>
           </a:p>
           <a:p>
@@ -12026,15 +12096,25 @@
               <a:spcAft>
                 <a:spcPts val="500"/>
               </a:spcAft>
-              <a:defRPr sz="1200">
+            </a:pPr>
+            <a:r>
+              <a:rPr sz="1200">
                 <a:solidFill>
                   <a:srgbClr val="1B1B2C"/>
                 </a:solidFill>
                 <a:latin typeface="Segoe UI"/>
-              </a:defRPr>
-            </a:pPr>
-            <a:r>
-              <a:t>• ADOPT Microsoft Copilot Adoption hub</a:t>
+              </a:rPr>
+              <a:t>• </a:t>
+            </a:r>
+            <a:r>
+              <a:rPr sz="1200" u="sng">
+                <a:solidFill>
+                  <a:srgbClr val="1A6FD6"/>
+                </a:solidFill>
+                <a:latin typeface="Segoe UI"/>
+                <a:hlinkClick r:id="rId9"/>
+              </a:rPr>
+              <a:t>ADOPT Microsoft Copilot Adoption hub</a:t>
             </a:r>
           </a:p>
         </p:txBody>

</xml_diff>

<commit_message>
Naming and accuracy audit: Microsoft 365 Copilot, factual fixes
Co-authored-by: Copilot <223556219+Copilot@users.noreply.github.com>
</commit_message>
<xml_diff>
--- a/slides/What to use when - Copilot and Cowork (Business - lite).pptx
+++ b/slides/What to use when - Copilot and Cowork (Business - lite).pptx
@@ -3179,7 +3179,7 @@
                 </a:solidFill>
                 <a:latin typeface="Segoe UI"/>
               </a:rPr>
-              <a:t>Microsoft 365 Copilot is your everyday AI assistant. Copilot Cowork is the AI coworker that does the work for you. This guide helps you pick the right one for each task. Every claim is grounded in Microsoft Learn or microsoft.com, with links at the bottom.</a:t>
+              <a:t>Microsoft 365 Copilot is your everyday AI assistant. Copilot Cowork is the AI coworker that does the work for you. This guide helps you pick the right one for each task. Every claim is grounded in Microsoft Learn or microsoft.com, with links at the bottom. Preview features are labelled and may change.</a:t>
             </a:r>
           </a:p>
         </p:txBody>
@@ -6036,7 +6036,7 @@
                 </a:solidFill>
                 <a:latin typeface="Segoe UI"/>
               </a:rPr>
-              <a:t>You can schedule this to run automatically by starting your prompt with "Create a skill where this occurs every Monday morning."</a:t>
+              <a:t>To automate this, save the prompt, then in Microsoft 365 Copilot hover the saved prompt and choose "Schedule this prompt". Use a skill separately when you want the...</a:t>
             </a:r>
           </a:p>
         </p:txBody>
@@ -8030,7 +8030,7 @@
                 </a:solidFill>
                 <a:latin typeface="Segoe UI"/>
               </a:rPr>
-              <a:t>This task features a scheduled prompt, which tells Cowork you want it to run automatically on a recurring basis. To create a scheduled prompt, simply describe what...</a:t>
+              <a:t>This task can use a scheduled prompt. In Microsoft 365 Copilot, save the prompt, hover it, choose "Schedule this prompt", and set the recurrence.</a:t>
             </a:r>
           </a:p>
         </p:txBody>
@@ -12114,7 +12114,7 @@
                 <a:latin typeface="Segoe UI"/>
                 <a:hlinkClick r:id="rId9"/>
               </a:rPr>
-              <a:t>ADOPT Microsoft Copilot Adoption hub</a:t>
+              <a:t>ADOPT Microsoft 365 Copilot Adoption hub</a:t>
             </a:r>
           </a:p>
         </p:txBody>
@@ -12459,7 +12459,7 @@
               </a:defRPr>
             </a:pPr>
             <a:r>
-              <a:t>• Take real action across M365 (send, schedule, create, post)</a:t>
+              <a:t>• Take real action across Microsoft 365 (send, schedule, create, post)</a:t>
             </a:r>
           </a:p>
         </p:txBody>
@@ -12788,7 +12788,7 @@
                 </a:solidFill>
                 <a:latin typeface="Segoe UI"/>
               </a:rPr>
-              <a:t>When the work involves an M365 app, you have more than one Copilot option. Some live inside the app, others act on its files and signals from their own surface. Pick by how much heavy lifting you need.</a:t>
+              <a:t>When the work involves a Microsoft 365 app, you have more than one Copilot option. Some live inside the app, others act on its files and signals from their own surface. Pick by how much heavy lifting you need.</a:t>
             </a:r>
           </a:p>
         </p:txBody>

</xml_diff>